<commit_message>
Saved content from 2025.
</commit_message>
<xml_diff>
--- a/etc/Envelopes.pptx
+++ b/etc/Envelopes.pptx
@@ -244,7 +244,7 @@
           <a:p>
             <a:fld id="{9F90DC42-5444-4165-8B49-A5A986D0EDD4}" type="datetimeFigureOut">
               <a:rPr lang="en-US" smtClean="0"/>
-              <a:t>8/27/2021</a:t>
+              <a:t>6/26/2025</a:t>
             </a:fld>
             <a:endParaRPr lang="en-US"/>
           </a:p>
@@ -4229,7 +4229,7 @@
                 <a:latin typeface="+mj-lt"/>
                 <a:cs typeface="Aharoni" panose="02010803020104030203" pitchFamily="2" charset="-79"/>
               </a:rPr>
-              <a:t>Closest to the Hole #3</a:t>
+              <a:t>Closest to the Hole #4</a:t>
             </a:r>
           </a:p>
         </p:txBody>
@@ -4322,7 +4322,7 @@
                 <a:latin typeface="+mj-lt"/>
                 <a:cs typeface="Aharoni" panose="02010803020104030203" pitchFamily="2" charset="-79"/>
               </a:rPr>
-              <a:t>Closest to the Hole #5</a:t>
+              <a:t>Closest to the Hole #9</a:t>
             </a:r>
           </a:p>
         </p:txBody>
@@ -4508,7 +4508,7 @@
                 <a:latin typeface="+mj-lt"/>
                 <a:cs typeface="Aharoni" panose="02010803020104030203" pitchFamily="2" charset="-79"/>
               </a:rPr>
-              <a:t>Closest to the Hole #15</a:t>
+              <a:t>Closest to the Hole #18</a:t>
             </a:r>
           </a:p>
         </p:txBody>
@@ -4601,7 +4601,7 @@
                 <a:latin typeface="+mj-lt"/>
                 <a:cs typeface="Aharoni" panose="02010803020104030203" pitchFamily="2" charset="-79"/>
               </a:rPr>
-              <a:t>Longest Drive #11</a:t>
+              <a:t>Longest Drive #10</a:t>
             </a:r>
           </a:p>
         </p:txBody>

</xml_diff>